<commit_message>
dpf: refresh team deck for multi-DPU + move internal S2 backup out of customer docs
Deck (html + pptx, both regenerated):
- title: 'Multi-DPU validated (S4 + S2 simultaneously)'
- topology: one operator -> two BF3 workers (:6443/:6444)
- bringup: config-driven (--worker, config.yaml); first boot = 2 console
  commands (password + dpf-firstboot-kick)
- caveats: multi-DPU now a capability, not a limitation; added CPU-routed
  data-plane caveat (eswitch offload = DPUService migration roadmap)
- demo: fleet_status.sh --frr

s2-standalone-backup-20260706/ (internal lab FRR config + MACs) moved
dpf/docs/ -> hbn_latest/backups/ so the customer tarball (dpf/ only)
no longer carries internal data.

Co-Authored-By: Claude Fable 5 <noreply@anthropic.com>
</commit_message>
<xml_diff>
--- a/hbn_latest/dpf/docs/dpf-hbn-deck-aviz.pptx
+++ b/hbn_latest/dpf/docs/dpf-hbn-deck-aviz.pptx
@@ -3264,7 +3264,7 @@
                 </a:solidFill>
                 <a:latin typeface="Calibri"/>
               </a:rPr>
-              <a:t>Validated end-to-end on S4  ·  DOCA v25.10.1  ·  run it with </a:t>
+              <a:t>Multi-DPU validated (S4 + S2 simultaneously)  ·  DOCA v25.10.1  ·  run it with </a:t>
             </a:r>
             <a:r>
               <a:rPr sz="1500" b="1">
@@ -3595,7 +3595,7 @@
                 </a:solidFill>
                 <a:latin typeface="Consolas"/>
               </a:rPr>
-              <a:t>./dpf/scripts/status_dpf.sh                                  </a:t>
+              <a:t>./dpf/scripts/fleet_status.sh --frr                          </a:t>
             </a:r>
             <a:r>
               <a:rPr sz="1300">
@@ -3604,7 +3604,7 @@
                 </a:solidFill>
                 <a:latin typeface="Consolas"/>
               </a:rPr>
-              <a:t># one-shot health</a:t>
+              <a:t># ALL DPUs: node/HBN/FRR</a:t>
             </a:r>
           </a:p>
         </p:txBody>
@@ -4913,7 +4913,7 @@
                 </a:solidFill>
                 <a:latin typeface="Calibri"/>
               </a:rPr>
-              <a:t>One DPU per DPF VM</a:t>
+              <a:t>Multi-DPU works</a:t>
             </a:r>
             <a:r>
               <a:rPr sz="1600" b="0">
@@ -4922,7 +4922,7 @@
                 </a:solidFill>
                 <a:latin typeface="Calibri"/>
               </a:rPr>
-              <a:t> — validated for a single BF3.</a:t>
+              <a:t> — one operator manages many BF3s (S4 :6443 + S2 :6444 validated simultaneously; unique apiserver_port per worker in config.yaml).</a:t>
             </a:r>
           </a:p>
           <a:p>
@@ -4968,6 +4968,43 @@
                 <a:spcPts val="0"/>
               </a:spcBef>
               <a:spcAft>
+                <a:spcPts val="1400"/>
+              </a:spcAft>
+            </a:pPr>
+            <a:r>
+              <a:rPr sz="1600" b="1">
+                <a:solidFill>
+                  <a:srgbClr val="9B57DE"/>
+                </a:solidFill>
+                <a:latin typeface="Calibri"/>
+              </a:rPr>
+              <a:t>▪  </a:t>
+            </a:r>
+            <a:r>
+              <a:rPr sz="1600" b="1">
+                <a:solidFill>
+                  <a:srgbClr val="E9EEF5"/>
+                </a:solidFill>
+                <a:latin typeface="Calibri"/>
+              </a:rPr>
+              <a:t>Fresh-flash first boot = 2 console commands</a:t>
+            </a:r>
+            <a:r>
+              <a:rPr sz="1600" b="0">
+                <a:solidFill>
+                  <a:srgbClr val="E9EEF5"/>
+                </a:solidFill>
+                <a:latin typeface="Calibri"/>
+              </a:rPr>
+              <a:t> — password + systemctl start dpf-firstboot-kick; later boots hands-off.</a:t>
+            </a:r>
+          </a:p>
+          <a:p>
+            <a:pPr>
+              <a:spcBef>
+                <a:spcPts val="0"/>
+              </a:spcBef>
+              <a:spcAft>
                 <a:spcPts val="800"/>
               </a:spcAft>
             </a:pPr>
@@ -4987,7 +5024,7 @@
                 </a:solidFill>
                 <a:latin typeface="Calibri"/>
               </a:rPr>
-              <a:t>Fresh-flash first boot is hands-on</a:t>
+              <a:t>Data plane is CPU-routed today</a:t>
             </a:r>
             <a:r>
               <a:rPr sz="1600" b="0">
@@ -4996,7 +5033,7 @@
                 </a:solidFill>
                 <a:latin typeface="Calibri"/>
               </a:rPr>
-              <a:t> — console password, dhclient oob_net0, enable sfc.service (all in QUICKSTART.md).</a:t>
+              <a:t> — fine for config/feature work; eswitch offload arrives with the DPUService migration (roadmap).</a:t>
             </a:r>
           </a:p>
         </p:txBody>
@@ -7987,7 +8024,7 @@
                 </a:solidFill>
                 <a:latin typeface="Consolas"/>
               </a:rPr>
-              <a:t>BF3 / BlueField-3</a:t>
+              <a:t>BF3 #1 (S4)</a:t>
             </a:r>
             <a:r>
               <a:rPr sz="1300">
@@ -7996,7 +8033,16 @@
                 </a:solidFill>
                 <a:latin typeface="Consolas"/>
               </a:rPr>
-              <a:t>  (S4 · OOB 10.20.13.249 · BMC 10.20.13.250)</a:t>
+              <a:t>  worker1 · apiserver :6443        </a:t>
+            </a:r>
+            <a:r>
+              <a:rPr sz="1300">
+                <a:solidFill>
+                  <a:srgbClr val="93A1B3"/>
+                </a:solidFill>
+                <a:latin typeface="Consolas"/>
+              </a:rPr>
+              <a:t># one operator,</a:t>
             </a:r>
           </a:p>
           <a:p>
@@ -8011,11 +8057,48 @@
             <a:r>
               <a:rPr sz="1300">
                 <a:solidFill>
+                  <a:srgbClr val="9B57DE"/>
+                </a:solidFill>
+                <a:latin typeface="Consolas"/>
+              </a:rPr>
+              <a:t>BF3 #2 (S2)</a:t>
+            </a:r>
+            <a:r>
+              <a:rPr sz="1300">
+                <a:solidFill>
                   <a:srgbClr val="CDD9E5"/>
                 </a:solidFill>
                 <a:latin typeface="Consolas"/>
               </a:rPr>
-              <a:t>   a Kubernetes WORKER node → runs HBN (FRR) as a pod</a:t>
+              <a:t>  worker2 · apiserver :6444        </a:t>
+            </a:r>
+            <a:r>
+              <a:rPr sz="1300">
+                <a:solidFill>
+                  <a:srgbClr val="93A1B3"/>
+                </a:solidFill>
+                <a:latin typeface="Consolas"/>
+              </a:rPr>
+              <a:t># many DPUs</a:t>
+            </a:r>
+          </a:p>
+          <a:p>
+            <a:pPr>
+              <a:lnSpc>
+                <a:spcPct val="115000"/>
+              </a:lnSpc>
+              <a:spcAft>
+                <a:spcPts val="100"/>
+              </a:spcAft>
+            </a:pPr>
+            <a:r>
+              <a:rPr sz="1300">
+                <a:solidFill>
+                  <a:srgbClr val="CDD9E5"/>
+                </a:solidFill>
+                <a:latin typeface="Consolas"/>
+              </a:rPr>
+              <a:t>   each BF3 = a Kubernetes WORKER node → runs HBN (FRR) as a pod</a:t>
             </a:r>
           </a:p>
           <a:p>
@@ -9055,7 +9138,7 @@
                 </a:solidFill>
                 <a:latin typeface="Calibri"/>
               </a:rPr>
-              <a:t>bringup_dpf.sh installs prereqs, creates the cluster, flashes the BF3</a:t>
+              <a:t>bringup_dpf.sh --worker worker1 — IPs/creds from config.yaml</a:t>
             </a:r>
           </a:p>
         </p:txBody>
@@ -9140,7 +9223,7 @@
                 </a:solidFill>
                 <a:latin typeface="Calibri"/>
               </a:rPr>
-              <a:t>set password · dhclient oob_net0 · enable sfc.service → BF3 joins</a:t>
+              <a:t>2 console commands: password + systemctl start dpf-firstboot-kick</a:t>
             </a:r>
           </a:p>
         </p:txBody>

</xml_diff>

<commit_message>
dpf: deck topology fix — each BF3 sits in its OWN x86 host (S4->.226, S2->.12)
Previous multi-DPU update showed two BF3s funneling into a single x86 host.

Co-Authored-By: Claude Fable 5 <noreply@anthropic.com>
</commit_message>
<xml_diff>
--- a/hbn_latest/dpf/docs/dpf-hbn-deck-aviz.pptx
+++ b/hbn_latest/dpf/docs/dpf-hbn-deck-aviz.pptx
@@ -8117,7 +8117,7 @@
                 </a:solidFill>
                 <a:latin typeface="Consolas"/>
               </a:rPr>
-              <a:t>        │  PCIe</a:t>
+              <a:t>        │  PCIe (each BF3 sits in its own x86 host)</a:t>
             </a:r>
           </a:p>
           <a:p>
@@ -8155,7 +8155,7 @@
                 </a:solidFill>
                 <a:latin typeface="Consolas"/>
               </a:rPr>
-              <a:t>x86 host</a:t>
+              <a:t>x86 hosts</a:t>
             </a:r>
             <a:r>
               <a:rPr sz="1300">
@@ -8164,7 +8164,7 @@
                 </a:solidFill>
                 <a:latin typeface="Consolas"/>
               </a:rPr>
-              <a:t>  (10.20.13.226)                       </a:t>
+              <a:t>  (S4 → 10.20.13.226 · S2 → 10.20.13.12)  </a:t>
             </a:r>
             <a:r>
               <a:rPr sz="1300">
@@ -8192,7 +8192,7 @@
                 </a:solidFill>
                 <a:latin typeface="Consolas"/>
               </a:rPr>
-              <a:t>   BF3 rshim (flash) · SR-IOV VFs (vf0..vf7)</a:t>
+              <a:t>   per host: BF3 rshim (flash) · SR-IOV VFs vf0..vf7</a:t>
             </a:r>
           </a:p>
         </p:txBody>

</xml_diff>

<commit_message>
dpf: deck — drop the CPU-routed caveat bullet (keep it in README/CHEATSHEET)
Co-Authored-By: Claude Fable 5 <noreply@anthropic.com>
</commit_message>
<xml_diff>
--- a/hbn_latest/dpf/docs/dpf-hbn-deck-aviz.pptx
+++ b/hbn_latest/dpf/docs/dpf-hbn-deck-aviz.pptx
@@ -4997,43 +4997,6 @@
                 <a:latin typeface="Calibri"/>
               </a:rPr>
               <a:t> — password + systemctl start dpf-firstboot-kick; later boots hands-off.</a:t>
-            </a:r>
-          </a:p>
-          <a:p>
-            <a:pPr>
-              <a:spcBef>
-                <a:spcPts val="0"/>
-              </a:spcBef>
-              <a:spcAft>
-                <a:spcPts val="800"/>
-              </a:spcAft>
-            </a:pPr>
-            <a:r>
-              <a:rPr sz="1600" b="1">
-                <a:solidFill>
-                  <a:srgbClr val="9B57DE"/>
-                </a:solidFill>
-                <a:latin typeface="Calibri"/>
-              </a:rPr>
-              <a:t>▪  </a:t>
-            </a:r>
-            <a:r>
-              <a:rPr sz="1600" b="1">
-                <a:solidFill>
-                  <a:srgbClr val="E9EEF5"/>
-                </a:solidFill>
-                <a:latin typeface="Calibri"/>
-              </a:rPr>
-              <a:t>Data plane is CPU-routed today</a:t>
-            </a:r>
-            <a:r>
-              <a:rPr sz="1600" b="0">
-                <a:solidFill>
-                  <a:srgbClr val="E9EEF5"/>
-                </a:solidFill>
-                <a:latin typeface="Calibri"/>
-              </a:rPr>
-              <a:t> — fine for config/feature work; eswitch offload arrives with the DPUService migration (roadmap).</a:t>
             </a:r>
           </a:p>
         </p:txBody>

</xml_diff>